<commit_message>
feat: complete v4.0 architecture, modularize UI, separate service layer, update dependencies to headless OpenCV, and establish docs
</commit_message>
<xml_diff>
--- a/test_data/test_sample_modified.pptx
+++ b/test_data/test_sample_modified.pptx
@@ -3113,7 +3113,7 @@
             <a:r>
               <a:rPr sz="1800">
                 <a:solidFill>
-                  <a:srgbClr val="FF0000"/>
+                  <a:srgbClr val="800080"/>
                 </a:solidFill>
               </a:rPr>
               <a:t>일반 텍스트 상자 (빨간색)</a:t>
@@ -3197,7 +3197,7 @@
                       <a:r>
                         <a:rPr>
                           <a:solidFill>
-                            <a:srgbClr val="FF0000"/>
+                            <a:srgbClr val="00FF00"/>
                           </a:solidFill>
                         </a:rPr>
                         <a:t>표 텍스트 (초록색)</a:t>

</xml_diff>